<commit_message>
soutenance: CNN-LSTM deployment, 1700-word blog, Azure reactivation guide
- predictor.py: resolve keras model_path relative to production dir (was absolute local path, would break on Azure)
- deploy_azure.sh: properly copy .keras + bundle files for CNN-LSTM deployment
- requirements-azure.txt: add tensorflow-cpu, relax version constraints
- blog: rewrite to 1733 words (OC requires 1500-2000, was 696)
- presentation.md/pdf/pptx: update to show cnn_lstm_glove as deployed model
- docs/AZURE_REACTIVATION.md: step-by-step guide to re-enable disabled subscription
- docs/SOUTENANCE_GUIDE.md: fix MLflow port (5001 to avoid AirTunes conflict on macOS)
- livrables: regenerate all 6 OC zips

Co-authored-by: Cursor <cursoragent@cursor.com>
</commit_message>
<xml_diff>
--- a/docs/presentation.pptx
+++ b/docs/presentation.pptx
@@ -3252,18 +3252,35 @@
               <a:rPr>
                 <a:latin typeface="Courier"/>
               </a:rPr>
+              <a:t>cnn_lstm_glove</a:t>
+            </a:r>
+            <a:r>
+              <a:rPr/>
+              <a:t> (Modèle sur mesure avancé — 5 Mo)</a:t>
+            </a:r>
+          </a:p>
+          <a:p>
+            <a:pPr lvl="0"/>
+            <a:r>
+              <a:rPr/>
+              <a:t>DistilBERT = meilleur modèle entraîné, trop lourd pour F1 (~250 Mo)</a:t>
+            </a:r>
+          </a:p>
+          <a:p>
+            <a:pPr lvl="0"/>
+            <a:r>
+              <a:rPr/>
+              <a:t>Fallback automatique : </a:t>
+            </a:r>
+            <a:r>
+              <a:rPr>
+                <a:latin typeface="Courier"/>
+              </a:rPr>
               <a:t>tfidf_logistic</a:t>
             </a:r>
             <a:r>
               <a:rPr/>
-              <a:t> (contrainte F1)</a:t>
-            </a:r>
-          </a:p>
-          <a:p>
-            <a:pPr lvl="0"/>
-            <a:r>
-              <a:rPr/>
-              <a:t>DistilBERT = meilleur modèle entraîné (MLflow)</a:t>
+              <a:t> si TensorFlow indisponible</a:t>
             </a:r>
           </a:p>
         </p:txBody>
@@ -3742,21 +3759,21 @@
             <a:pPr lvl="0"/>
             <a:r>
               <a:rPr/>
-              <a:t>TF-IDF logistic = modèle déployé sur Azure F1</a:t>
+              <a:t>CNN-LSTM + GloVe = modèle sur mesure avancé déployé (69,4 % F1, 5 Mo)</a:t>
             </a:r>
           </a:p>
           <a:p>
             <a:pPr lvl="0"/>
             <a:r>
               <a:rPr/>
-              <a:t>MLOps opérationnel (tracking, CI, monitoring)</a:t>
+              <a:t>MLOps opérationnel (tracking, CI, monitoring, alertes)</a:t>
             </a:r>
           </a:p>
           <a:p>
             <a:pPr lvl="0"/>
             <a:r>
               <a:rPr/>
-              <a:t>Piste d’évolution : plus de données, active learning via feedback</a:t>
+              <a:t>Piste d’évolution : données augmentées via feedback App Insights, active learning</a:t>
             </a:r>
           </a:p>
         </p:txBody>

</xml_diff>

<commit_message>
Soutenance prep: executed notebooks with outputs, real captures, refreshed deliverables
- Notebooks 01/02 fully re-executed (EDA plots, TF-IDF runs logged to MLflow)
- Real MLflow UI runs table, GitHub Actions, Streamlit demo, App Insights captures
- Streamlit .env loading fix, streamlit demo capture script
- Regenerated presentation PDF/PPTX and deliverable zips

Co-authored-by: Cursor <cursoragent@cursor.com>
</commit_message>
<xml_diff>
--- a/docs/presentation.pptx
+++ b/docs/presentation.pptx
@@ -20,6 +20,8 @@
     <p:sldId id="268" r:id="rId14"/>
     <p:sldId id="269" r:id="rId15"/>
     <p:sldId id="270" r:id="rId16"/>
+    <p:sldId id="271" r:id="rId17"/>
+    <p:sldId id="272" r:id="rId18"/>
   </p:sldIdLst>
   <p:sldSz cx="9144000" cy="5143500" type="screen16x9"/>
   <p:notesSz cx="6858000" cy="9144000"/>
@@ -3176,118 +3178,9 @@
           <a:chExt cx="0" cy="0"/>
         </a:xfrm>
       </p:grpSpPr>
-      <p:sp>
-        <p:nvSpPr>
-          <p:cNvPr id="4" name="Text Placeholder 3"/>
-          <p:cNvSpPr>
-            <a:spLocks noGrp="1"/>
-          </p:cNvSpPr>
-          <p:nvPr>
-            <p:ph idx="2" sz="half" type="body"/>
-          </p:nvPr>
-        </p:nvSpPr>
-        <p:spPr/>
-        <p:txBody>
-          <a:bodyPr/>
-          <a:lstStyle/>
-          <a:p>
-            <a:pPr lvl="0" indent="0" marL="0">
-              <a:spcBef>
-                <a:spcPts val="3000"/>
-              </a:spcBef>
-              <a:buNone/>
-            </a:pPr>
-            <a:r>
-              <a:rPr b="1"/>
-              <a:t>Slide 8 — Mise en production</a:t>
-            </a:r>
-          </a:p>
-          <a:p>
-            <a:pPr lvl="0"/>
-            <a:r>
-              <a:rPr/>
-              <a:t>API FastAPI : </a:t>
-            </a:r>
-            <a:r>
-              <a:rPr>
-                <a:latin typeface="Courier"/>
-              </a:rPr>
-              <a:t>/predict</a:t>
-            </a:r>
-            <a:r>
-              <a:rPr/>
-              <a:t>, </a:t>
-            </a:r>
-            <a:r>
-              <a:rPr>
-                <a:latin typeface="Courier"/>
-              </a:rPr>
-              <a:t>/health</a:t>
-            </a:r>
-            <a:r>
-              <a:rPr/>
-              <a:t>, </a:t>
-            </a:r>
-            <a:r>
-              <a:rPr>
-                <a:latin typeface="Courier"/>
-              </a:rPr>
-              <a:t>/feedback</a:t>
-            </a:r>
-          </a:p>
-          <a:p>
-            <a:pPr lvl="0"/>
-            <a:r>
-              <a:rPr/>
-              <a:t>Déploiement : Azure Web App F1</a:t>
-            </a:r>
-          </a:p>
-          <a:p>
-            <a:pPr lvl="0"/>
-            <a:r>
-              <a:rPr/>
-              <a:t>Modèle déployé : </a:t>
-            </a:r>
-            <a:r>
-              <a:rPr>
-                <a:latin typeface="Courier"/>
-              </a:rPr>
-              <a:t>cnn_lstm_glove</a:t>
-            </a:r>
-            <a:r>
-              <a:rPr/>
-              <a:t> (Modèle sur mesure avancé — 5 Mo)</a:t>
-            </a:r>
-          </a:p>
-          <a:p>
-            <a:pPr lvl="0"/>
-            <a:r>
-              <a:rPr/>
-              <a:t>DistilBERT = meilleur modèle entraîné, trop lourd pour F1 (~250 Mo)</a:t>
-            </a:r>
-          </a:p>
-          <a:p>
-            <a:pPr lvl="0"/>
-            <a:r>
-              <a:rPr/>
-              <a:t>Fallback automatique : </a:t>
-            </a:r>
-            <a:r>
-              <a:rPr>
-                <a:latin typeface="Courier"/>
-              </a:rPr>
-              <a:t>tfidf_logistic</a:t>
-            </a:r>
-            <a:r>
-              <a:rPr/>
-              <a:t> si TensorFlow indisponible</a:t>
-            </a:r>
-          </a:p>
-        </p:txBody>
-      </p:sp>
       <p:pic>
         <p:nvPicPr>
-          <p:cNvPr descr="screenshots/azure_api_health.png" id="0" name="Picture 1"/>
+          <p:cNvPr descr="screenshots/mlflow_model_comparison.png" id="0" name="Picture 1"/>
           <p:cNvPicPr>
             <a:picLocks noGrp="1" noChangeAspect="1"/>
           </p:cNvPicPr>
@@ -3301,8 +3194,8 @@
         </p:blipFill>
         <p:spPr bwMode="auto">
           <a:xfrm>
-            <a:off x="3568700" y="711200"/>
-            <a:ext cx="5105400" cy="2870200"/>
+            <a:off x="1663700" y="1193800"/>
+            <a:ext cx="5816600" cy="2882900"/>
           </a:xfrm>
           <a:prstGeom prst="rect">
             <a:avLst/>
@@ -3323,8 +3216,8 @@
         </p:nvSpPr>
         <p:spPr>
           <a:xfrm>
-            <a:off x="3568700" y="4076700"/>
-            <a:ext cx="5105400" cy="508000"/>
+            <a:off x="457200" y="4076700"/>
+            <a:ext cx="8229600" cy="508000"/>
           </a:xfrm>
           <a:prstGeom prst="rect">
             <a:avLst/>
@@ -3340,7 +3233,67 @@
             </a:pPr>
             <a:r>
               <a:rPr/>
-              <a:t>API Azure /health</a:t>
+              <a:t>Comparaison MLflow</a:t>
+            </a:r>
+          </a:p>
+        </p:txBody>
+      </p:sp>
+      <p:pic>
+        <p:nvPicPr>
+          <p:cNvPr descr="screenshots/mlflow_ui_runs.png" id="0" name="Picture 1"/>
+          <p:cNvPicPr>
+            <a:picLocks noGrp="1" noChangeAspect="1"/>
+          </p:cNvPicPr>
+          <p:nvPr/>
+        </p:nvPicPr>
+        <p:blipFill>
+          <a:blip r:embed="rId3"/>
+          <a:stretch>
+            <a:fillRect/>
+          </a:stretch>
+        </p:blipFill>
+        <p:spPr bwMode="auto">
+          <a:xfrm>
+            <a:off x="2095500" y="1193800"/>
+            <a:ext cx="4953000" cy="2882900"/>
+          </a:xfrm>
+          <a:prstGeom prst="rect">
+            <a:avLst/>
+          </a:prstGeom>
+          <a:noFill/>
+          <a:ln w="9525">
+            <a:noFill/>
+            <a:headEnd/>
+            <a:tailEnd/>
+          </a:ln>
+        </p:spPr>
+      </p:pic>
+      <p:sp>
+        <p:nvSpPr>
+          <p:cNvPr id="1" name="TextBox 3"/>
+          <p:cNvSpPr txBox="1"/>
+          <p:nvPr/>
+        </p:nvSpPr>
+        <p:spPr>
+          <a:xfrm>
+            <a:off x="457200" y="4076700"/>
+            <a:ext cx="8229600" cy="508000"/>
+          </a:xfrm>
+          <a:prstGeom prst="rect">
+            <a:avLst/>
+          </a:prstGeom>
+          <a:noFill/>
+        </p:spPr>
+        <p:txBody>
+          <a:bodyPr/>
+          <a:lstStyle/>
+          <a:p>
+            <a:pPr lvl="0" indent="0" marL="0" algn="ctr">
+              <a:buNone/>
+            </a:pPr>
+            <a:r>
+              <a:rPr/>
+              <a:t>MLflow UI — runs</a:t>
             </a:r>
           </a:p>
         </p:txBody>
@@ -3390,42 +3343,69 @@
             </a:pPr>
             <a:r>
               <a:rPr b="1"/>
-              <a:t>Slide 9 — Interface Streamlit</a:t>
+              <a:t>Slide 7 — MLOps : principes</a:t>
             </a:r>
           </a:p>
           <a:p>
             <a:pPr lvl="0"/>
             <a:r>
-              <a:rPr/>
-              <a:t>Saisie tweet → appel API cloud → prédiction</a:t>
+              <a:rPr b="1"/>
+              <a:t>Tracking</a:t>
+            </a:r>
+            <a:r>
+              <a:rPr/>
+              <a:t> : MLflow (params, metrics, artifacts)</a:t>
             </a:r>
           </a:p>
           <a:p>
             <a:pPr lvl="0"/>
             <a:r>
-              <a:rPr/>
-              <a:t>Validation utilisateur (Oui / Non)</a:t>
+              <a:rPr b="1"/>
+              <a:t>Versioning</a:t>
+            </a:r>
+            <a:r>
+              <a:rPr/>
+              <a:t> : Git + GitHub</a:t>
             </a:r>
           </a:p>
           <a:p>
             <a:pPr lvl="0"/>
             <a:r>
-              <a:rPr/>
-              <a:t>Trace App Insights si erreur</a:t>
+              <a:rPr b="1"/>
+              <a:t>Tests</a:t>
+            </a:r>
+            <a:r>
+              <a:rPr/>
+              <a:t> : pytest (11 tests)</a:t>
             </a:r>
           </a:p>
           <a:p>
             <a:pPr lvl="0"/>
             <a:r>
-              <a:rPr/>
-              <a:t>Alerte : 3 erreurs / 5 min</a:t>
+              <a:rPr b="1"/>
+              <a:t>CI/CD</a:t>
+            </a:r>
+            <a:r>
+              <a:rPr/>
+              <a:t> : GitHub Actions</a:t>
+            </a:r>
+          </a:p>
+          <a:p>
+            <a:pPr lvl="0"/>
+            <a:r>
+              <a:rPr b="1"/>
+              <a:t>Monitoring</a:t>
+            </a:r>
+            <a:r>
+              <a:rPr/>
+              <a:t> : Azure Application Insights</a:t>
             </a:r>
           </a:p>
         </p:txBody>
       </p:sp>
       <p:pic>
         <p:nvPicPr>
-          <p:cNvPr descr="screenshots/streamlit_demo.png" id="0" name="Picture 1"/>
+          <p:cNvPr descr="screenshots/github_actions_ci.png" id="0" name="Picture 1"/>
           <p:cNvPicPr>
             <a:picLocks noGrp="1" noChangeAspect="1"/>
           </p:cNvPicPr>
@@ -3439,7 +3419,7 @@
         </p:blipFill>
         <p:spPr bwMode="auto">
           <a:xfrm>
-            <a:off x="3568700" y="711200"/>
+            <a:off x="3568700" y="698500"/>
             <a:ext cx="5105400" cy="2870200"/>
           </a:xfrm>
           <a:prstGeom prst="rect">
@@ -3478,7 +3458,7 @@
             </a:pPr>
             <a:r>
               <a:rPr/>
-              <a:t>Streamlit</a:t>
+              <a:t>GitHub Actions CI</a:t>
             </a:r>
           </a:p>
         </p:txBody>
@@ -3528,35 +3508,95 @@
             </a:pPr>
             <a:r>
               <a:rPr b="1"/>
-              <a:t>Slide 10 — Suivi production</a:t>
+              <a:t>Slide 8 — Mise en production</a:t>
             </a:r>
           </a:p>
           <a:p>
             <a:pPr lvl="0"/>
             <a:r>
               <a:rPr/>
-              <a:t>Traces : texte, prédiction, timestamp</a:t>
+              <a:t>API FastAPI : </a:t>
+            </a:r>
+            <a:r>
+              <a:rPr>
+                <a:latin typeface="Courier"/>
+              </a:rPr>
+              <a:t>/predict</a:t>
+            </a:r>
+            <a:r>
+              <a:rPr/>
+              <a:t>, </a:t>
+            </a:r>
+            <a:r>
+              <a:rPr>
+                <a:latin typeface="Courier"/>
+              </a:rPr>
+              <a:t>/health</a:t>
+            </a:r>
+            <a:r>
+              <a:rPr/>
+              <a:t>, </a:t>
+            </a:r>
+            <a:r>
+              <a:rPr>
+                <a:latin typeface="Courier"/>
+              </a:rPr>
+              <a:t>/feedback</a:t>
             </a:r>
           </a:p>
           <a:p>
             <a:pPr lvl="0"/>
             <a:r>
               <a:rPr/>
-              <a:t>Alertes configurées dans App Insights</a:t>
+              <a:t>Déploiement : Azure Web App F1</a:t>
             </a:r>
           </a:p>
           <a:p>
             <a:pPr lvl="0"/>
             <a:r>
               <a:rPr/>
-              <a:t>Boucle d’amélioration : collecte → analyse → réentraînement → MLflow compare → promotion</a:t>
+              <a:t>Modèle déployé : </a:t>
+            </a:r>
+            <a:r>
+              <a:rPr>
+                <a:latin typeface="Courier"/>
+              </a:rPr>
+              <a:t>cnn_lstm_glove</a:t>
+            </a:r>
+            <a:r>
+              <a:rPr/>
+              <a:t> (Modèle sur mesure avancé — 5 Mo)</a:t>
+            </a:r>
+          </a:p>
+          <a:p>
+            <a:pPr lvl="0"/>
+            <a:r>
+              <a:rPr/>
+              <a:t>DistilBERT = meilleur modèle entraîné, trop lourd pour F1 (~250 Mo)</a:t>
+            </a:r>
+          </a:p>
+          <a:p>
+            <a:pPr lvl="0"/>
+            <a:r>
+              <a:rPr/>
+              <a:t>Fallback automatique : </a:t>
+            </a:r>
+            <a:r>
+              <a:rPr>
+                <a:latin typeface="Courier"/>
+              </a:rPr>
+              <a:t>tfidf_logistic</a:t>
+            </a:r>
+            <a:r>
+              <a:rPr/>
+              <a:t> si TensorFlow indisponible</a:t>
             </a:r>
           </a:p>
         </p:txBody>
       </p:sp>
       <p:pic>
         <p:nvPicPr>
-          <p:cNvPr descr="screenshots/app_insights_traces.png" id="0" name="Picture 1"/>
+          <p:cNvPr descr="screenshots/azure_api_health.png" id="0" name="Picture 1"/>
           <p:cNvPicPr>
             <a:picLocks noGrp="1" noChangeAspect="1"/>
           </p:cNvPicPr>
@@ -3570,8 +3610,8 @@
         </p:blipFill>
         <p:spPr bwMode="auto">
           <a:xfrm>
-            <a:off x="3568700" y="711200"/>
-            <a:ext cx="5105400" cy="2870200"/>
+            <a:off x="3568700" y="368300"/>
+            <a:ext cx="5105400" cy="3543300"/>
           </a:xfrm>
           <a:prstGeom prst="rect">
             <a:avLst/>
@@ -3609,7 +3649,7 @@
             </a:pPr>
             <a:r>
               <a:rPr/>
-              <a:t>Application Insights</a:t>
+              <a:t>API Azure /health</a:t>
             </a:r>
           </a:p>
         </p:txBody>
@@ -3638,12 +3678,12 @@
       </p:grpSpPr>
       <p:sp>
         <p:nvSpPr>
-          <p:cNvPr id="3" name="Content Placeholder 2"/>
-          <p:cNvSpPr>
-            <a:spLocks noGrp="1"/>
-          </p:cNvSpPr>
-          <p:nvPr>
-            <p:ph idx="1"/>
+          <p:cNvPr id="4" name="Text Placeholder 3"/>
+          <p:cNvSpPr>
+            <a:spLocks noGrp="1"/>
+          </p:cNvSpPr>
+          <p:nvPr>
+            <p:ph idx="2" sz="half" type="body"/>
           </p:nvPr>
         </p:nvSpPr>
         <p:spPr/>
@@ -3659,43 +3699,95 @@
             </a:pPr>
             <a:r>
               <a:rPr b="1"/>
-              <a:t>Slide 11 — Démonstration live</a:t>
-            </a:r>
-          </a:p>
-          <a:p>
-            <a:pPr lvl="0" indent="-342900" marL="342900">
-              <a:buAutoNum type="arabicPeriod"/>
+              <a:t>Slide 9 — Interface Streamlit</a:t>
+            </a:r>
+          </a:p>
+          <a:p>
+            <a:pPr lvl="0"/>
+            <a:r>
+              <a:rPr/>
+              <a:t>Saisie tweet → appel API cloud → prédiction</a:t>
+            </a:r>
+          </a:p>
+          <a:p>
+            <a:pPr lvl="0"/>
+            <a:r>
+              <a:rPr/>
+              <a:t>Validation utilisateur (Oui / Non)</a:t>
+            </a:r>
+          </a:p>
+          <a:p>
+            <a:pPr lvl="0"/>
+            <a:r>
+              <a:rPr/>
+              <a:t>Trace App Insights si erreur</a:t>
+            </a:r>
+          </a:p>
+          <a:p>
+            <a:pPr lvl="0"/>
+            <a:r>
+              <a:rPr/>
+              <a:t>Alerte : 3 erreurs / 5 min</a:t>
+            </a:r>
+          </a:p>
+        </p:txBody>
+      </p:sp>
+      <p:pic>
+        <p:nvPicPr>
+          <p:cNvPr descr="screenshots/streamlit_demo.png" id="0" name="Picture 1"/>
+          <p:cNvPicPr>
+            <a:picLocks noGrp="1" noChangeAspect="1"/>
+          </p:cNvPicPr>
+          <p:nvPr/>
+        </p:nvPicPr>
+        <p:blipFill>
+          <a:blip r:embed="rId2"/>
+          <a:stretch>
+            <a:fillRect/>
+          </a:stretch>
+        </p:blipFill>
+        <p:spPr bwMode="auto">
+          <a:xfrm>
+            <a:off x="3568700" y="368300"/>
+            <a:ext cx="5105400" cy="3543300"/>
+          </a:xfrm>
+          <a:prstGeom prst="rect">
+            <a:avLst/>
+          </a:prstGeom>
+          <a:noFill/>
+          <a:ln w="9525">
+            <a:noFill/>
+            <a:headEnd/>
+            <a:tailEnd/>
+          </a:ln>
+        </p:spPr>
+      </p:pic>
+      <p:sp>
+        <p:nvSpPr>
+          <p:cNvPr id="1" name="TextBox 3"/>
+          <p:cNvSpPr txBox="1"/>
+          <p:nvPr/>
+        </p:nvSpPr>
+        <p:spPr>
+          <a:xfrm>
+            <a:off x="3568700" y="4076700"/>
+            <a:ext cx="5105400" cy="508000"/>
+          </a:xfrm>
+          <a:prstGeom prst="rect">
+            <a:avLst/>
+          </a:prstGeom>
+          <a:noFill/>
+        </p:spPr>
+        <p:txBody>
+          <a:bodyPr/>
+          <a:lstStyle/>
+          <a:p>
+            <a:pPr lvl="0" indent="0" marL="0" algn="ctr">
+              <a:buNone/>
             </a:pPr>
             <a:r>
               <a:rPr/>
-              <a:t>Tweet positif → prédiction positive</a:t>
-            </a:r>
-          </a:p>
-          <a:p>
-            <a:pPr lvl="0" indent="-342900" marL="342900">
-              <a:buAutoNum type="arabicPeriod"/>
-            </a:pPr>
-            <a:r>
-              <a:rPr/>
-              <a:t>Tweet négatif → prédiction négative</a:t>
-            </a:r>
-          </a:p>
-          <a:p>
-            <a:pPr lvl="0" indent="-342900" marL="342900">
-              <a:buAutoNum type="arabicPeriod"/>
-            </a:pPr>
-            <a:r>
-              <a:rPr/>
-              <a:t>Feedback incorrect → trace App Insights</a:t>
-            </a:r>
-          </a:p>
-          <a:p>
-            <a:pPr lvl="0" indent="-342900" marL="342900">
-              <a:buAutoNum type="arabicPeriod"/>
-            </a:pPr>
-            <a:r>
-              <a:rPr/>
-              <a:t>GitHub Actions vert (11 tests)</a:t>
+              <a:t>Streamlit</a:t>
             </a:r>
           </a:p>
         </p:txBody>
@@ -3724,12 +3816,12 @@
       </p:grpSpPr>
       <p:sp>
         <p:nvSpPr>
-          <p:cNvPr id="3" name="Content Placeholder 2"/>
-          <p:cNvSpPr>
-            <a:spLocks noGrp="1"/>
-          </p:cNvSpPr>
-          <p:nvPr>
-            <p:ph idx="1"/>
+          <p:cNvPr id="4" name="Text Placeholder 3"/>
+          <p:cNvSpPr>
+            <a:spLocks noGrp="1"/>
+          </p:cNvSpPr>
+          <p:nvPr>
+            <p:ph idx="2" sz="half" type="body"/>
           </p:nvPr>
         </p:nvSpPr>
         <p:spPr/>
@@ -3745,35 +3837,88 @@
             </a:pPr>
             <a:r>
               <a:rPr b="1"/>
-              <a:t>Slide 12 — Conclusion</a:t>
+              <a:t>Slide 10 — Suivi production</a:t>
             </a:r>
           </a:p>
           <a:p>
             <a:pPr lvl="0"/>
             <a:r>
               <a:rPr/>
-              <a:t>DistilBERT = meilleur modèle entraîné (81,5 % F1)</a:t>
+              <a:t>Traces : texte, prédiction, timestamp</a:t>
             </a:r>
           </a:p>
           <a:p>
             <a:pPr lvl="0"/>
             <a:r>
               <a:rPr/>
-              <a:t>CNN-LSTM + GloVe = modèle sur mesure avancé déployé (69,4 % F1, 5 Mo)</a:t>
+              <a:t>Alertes configurées dans App Insights</a:t>
             </a:r>
           </a:p>
           <a:p>
             <a:pPr lvl="0"/>
             <a:r>
               <a:rPr/>
-              <a:t>MLOps opérationnel (tracking, CI, monitoring, alertes)</a:t>
-            </a:r>
-          </a:p>
-          <a:p>
-            <a:pPr lvl="0"/>
-            <a:r>
-              <a:rPr/>
-              <a:t>Piste d’évolution : données augmentées via feedback App Insights, active learning</a:t>
+              <a:t>Boucle d’amélioration : collecte → analyse → réentraînement → MLflow compare → promotion</a:t>
+            </a:r>
+          </a:p>
+        </p:txBody>
+      </p:sp>
+      <p:pic>
+        <p:nvPicPr>
+          <p:cNvPr descr="screenshots/app_insights_traces.png" id="0" name="Picture 1"/>
+          <p:cNvPicPr>
+            <a:picLocks noGrp="1" noChangeAspect="1"/>
+          </p:cNvPicPr>
+          <p:nvPr/>
+        </p:nvPicPr>
+        <p:blipFill>
+          <a:blip r:embed="rId2"/>
+          <a:stretch>
+            <a:fillRect/>
+          </a:stretch>
+        </p:blipFill>
+        <p:spPr bwMode="auto">
+          <a:xfrm>
+            <a:off x="3568700" y="1257300"/>
+            <a:ext cx="5105400" cy="1765300"/>
+          </a:xfrm>
+          <a:prstGeom prst="rect">
+            <a:avLst/>
+          </a:prstGeom>
+          <a:noFill/>
+          <a:ln w="9525">
+            <a:noFill/>
+            <a:headEnd/>
+            <a:tailEnd/>
+          </a:ln>
+        </p:spPr>
+      </p:pic>
+      <p:sp>
+        <p:nvSpPr>
+          <p:cNvPr id="1" name="TextBox 3"/>
+          <p:cNvSpPr txBox="1"/>
+          <p:nvPr/>
+        </p:nvSpPr>
+        <p:spPr>
+          <a:xfrm>
+            <a:off x="3568700" y="4076700"/>
+            <a:ext cx="5105400" cy="508000"/>
+          </a:xfrm>
+          <a:prstGeom prst="rect">
+            <a:avLst/>
+          </a:prstGeom>
+          <a:noFill/>
+        </p:spPr>
+        <p:txBody>
+          <a:bodyPr/>
+          <a:lstStyle/>
+          <a:p>
+            <a:pPr lvl="0" indent="0" marL="0" algn="ctr">
+              <a:buNone/>
+            </a:pPr>
+            <a:r>
+              <a:rPr/>
+              <a:t>Application Insights</a:t>
             </a:r>
           </a:p>
         </p:txBody>
@@ -3823,6 +3968,170 @@
             </a:pPr>
             <a:r>
               <a:rPr b="1"/>
+              <a:t>Slide 11 — Démonstration live</a:t>
+            </a:r>
+          </a:p>
+          <a:p>
+            <a:pPr lvl="0" indent="-342900" marL="342900">
+              <a:buAutoNum type="arabicPeriod"/>
+            </a:pPr>
+            <a:r>
+              <a:rPr/>
+              <a:t>Tweet positif → prédiction positive</a:t>
+            </a:r>
+          </a:p>
+          <a:p>
+            <a:pPr lvl="0" indent="-342900" marL="342900">
+              <a:buAutoNum type="arabicPeriod"/>
+            </a:pPr>
+            <a:r>
+              <a:rPr/>
+              <a:t>Tweet négatif → prédiction négative</a:t>
+            </a:r>
+          </a:p>
+          <a:p>
+            <a:pPr lvl="0" indent="-342900" marL="342900">
+              <a:buAutoNum type="arabicPeriod"/>
+            </a:pPr>
+            <a:r>
+              <a:rPr/>
+              <a:t>Feedback incorrect → trace App Insights</a:t>
+            </a:r>
+          </a:p>
+          <a:p>
+            <a:pPr lvl="0" indent="-342900" marL="342900">
+              <a:buAutoNum type="arabicPeriod"/>
+            </a:pPr>
+            <a:r>
+              <a:rPr/>
+              <a:t>GitHub Actions vert (11 tests)</a:t>
+            </a:r>
+          </a:p>
+        </p:txBody>
+      </p:sp>
+    </p:spTree>
+  </p:cSld>
+</p:sld>
+</file>
+
+<file path=ppt/slides/slide16.xml><?xml version="1.0" encoding="utf-8"?>
+<p:sld xmlns:a="http://schemas.openxmlformats.org/drawingml/2006/main" xmlns:r="http://schemas.openxmlformats.org/officeDocument/2006/relationships" xmlns:p="http://schemas.openxmlformats.org/presentationml/2006/main">
+  <p:cSld>
+    <p:spTree>
+      <p:nvGrpSpPr>
+        <p:cNvPr id="1" name=""/>
+        <p:cNvGrpSpPr/>
+        <p:nvPr/>
+      </p:nvGrpSpPr>
+      <p:grpSpPr>
+        <a:xfrm>
+          <a:off x="0" y="0"/>
+          <a:ext cx="0" cy="0"/>
+          <a:chOff x="0" y="0"/>
+          <a:chExt cx="0" cy="0"/>
+        </a:xfrm>
+      </p:grpSpPr>
+      <p:sp>
+        <p:nvSpPr>
+          <p:cNvPr id="3" name="Content Placeholder 2"/>
+          <p:cNvSpPr>
+            <a:spLocks noGrp="1"/>
+          </p:cNvSpPr>
+          <p:nvPr>
+            <p:ph idx="1"/>
+          </p:nvPr>
+        </p:nvSpPr>
+        <p:spPr/>
+        <p:txBody>
+          <a:bodyPr/>
+          <a:lstStyle/>
+          <a:p>
+            <a:pPr lvl="0" indent="0" marL="0">
+              <a:spcBef>
+                <a:spcPts val="3000"/>
+              </a:spcBef>
+              <a:buNone/>
+            </a:pPr>
+            <a:r>
+              <a:rPr b="1"/>
+              <a:t>Slide 12 — Conclusion</a:t>
+            </a:r>
+          </a:p>
+          <a:p>
+            <a:pPr lvl="0"/>
+            <a:r>
+              <a:rPr/>
+              <a:t>DistilBERT = meilleur modèle entraîné (81,5 % F1)</a:t>
+            </a:r>
+          </a:p>
+          <a:p>
+            <a:pPr lvl="0"/>
+            <a:r>
+              <a:rPr/>
+              <a:t>CNN-LSTM + GloVe = modèle sur mesure avancé déployé (69,4 % F1, 5 Mo)</a:t>
+            </a:r>
+          </a:p>
+          <a:p>
+            <a:pPr lvl="0"/>
+            <a:r>
+              <a:rPr/>
+              <a:t>MLOps opérationnel (tracking, CI, monitoring, alertes)</a:t>
+            </a:r>
+          </a:p>
+          <a:p>
+            <a:pPr lvl="0"/>
+            <a:r>
+              <a:rPr/>
+              <a:t>Piste d’évolution : données augmentées via feedback App Insights, active learning</a:t>
+            </a:r>
+          </a:p>
+        </p:txBody>
+      </p:sp>
+    </p:spTree>
+  </p:cSld>
+</p:sld>
+</file>
+
+<file path=ppt/slides/slide17.xml><?xml version="1.0" encoding="utf-8"?>
+<p:sld xmlns:a="http://schemas.openxmlformats.org/drawingml/2006/main" xmlns:r="http://schemas.openxmlformats.org/officeDocument/2006/relationships" xmlns:p="http://schemas.openxmlformats.org/presentationml/2006/main">
+  <p:cSld>
+    <p:spTree>
+      <p:nvGrpSpPr>
+        <p:cNvPr id="1" name=""/>
+        <p:cNvGrpSpPr/>
+        <p:nvPr/>
+      </p:nvGrpSpPr>
+      <p:grpSpPr>
+        <a:xfrm>
+          <a:off x="0" y="0"/>
+          <a:ext cx="0" cy="0"/>
+          <a:chOff x="0" y="0"/>
+          <a:chExt cx="0" cy="0"/>
+        </a:xfrm>
+      </p:grpSpPr>
+      <p:sp>
+        <p:nvSpPr>
+          <p:cNvPr id="3" name="Content Placeholder 2"/>
+          <p:cNvSpPr>
+            <a:spLocks noGrp="1"/>
+          </p:cNvSpPr>
+          <p:nvPr>
+            <p:ph idx="1"/>
+          </p:nvPr>
+        </p:nvSpPr>
+        <p:spPr/>
+        <p:txBody>
+          <a:bodyPr/>
+          <a:lstStyle/>
+          <a:p>
+            <a:pPr lvl="0" indent="0" marL="0">
+              <a:spcBef>
+                <a:spcPts val="3000"/>
+              </a:spcBef>
+              <a:buNone/>
+            </a:pPr>
+            <a:r>
+              <a:rPr b="1"/>
               <a:t>Annexes pour l’évaluateur</a:t>
             </a:r>
           </a:p>
@@ -4101,12 +4410,12 @@
       </p:grpSpPr>
       <p:sp>
         <p:nvSpPr>
-          <p:cNvPr id="3" name="Content Placeholder 2"/>
-          <p:cNvSpPr>
-            <a:spLocks noGrp="1"/>
-          </p:cNvSpPr>
-          <p:nvPr>
-            <p:ph idx="1"/>
+          <p:cNvPr id="4" name="Text Placeholder 3"/>
+          <p:cNvSpPr>
+            <a:spLocks noGrp="1"/>
+          </p:cNvSpPr>
+          <p:nvPr>
+            <p:ph idx="2" sz="half" type="body"/>
           </p:nvPr>
         </p:nvSpPr>
         <p:spPr/>
@@ -4122,37 +4431,81 @@
             </a:pPr>
             <a:r>
               <a:rPr b="1"/>
-              <a:t>Slide 3 — Approche 1 : Modèles simples</a:t>
+              <a:t>Slide 2b — Exploration des données (EDA)</a:t>
             </a:r>
           </a:p>
           <a:p>
             <a:pPr lvl="0"/>
             <a:r>
               <a:rPr/>
-              <a:t>TF-IDF (5000 features)</a:t>
+              <a:t>Dataset parfaitement équilibré : 800k négatifs / 800k positifs</a:t>
             </a:r>
           </a:p>
           <a:p>
             <a:pPr lvl="0"/>
             <a:r>
               <a:rPr/>
-              <a:t>Régression logistique : F1 test ~76,4 % (50k)</a:t>
-            </a:r>
-          </a:p>
-          <a:p>
-            <a:pPr lvl="0"/>
-            <a:r>
-              <a:rPr/>
-              <a:t>Random Forest : F1 test ~72,5 %</a:t>
-            </a:r>
-          </a:p>
-          <a:p>
-            <a:pPr lvl="0" indent="0" marL="0">
+              <a:t>Tweets courts : majorité entre 5 et 15 mots</a:t>
+            </a:r>
+          </a:p>
+        </p:txBody>
+      </p:sp>
+      <p:pic>
+        <p:nvPicPr>
+          <p:cNvPr descr="screenshots/eda_class_balance.png" id="0" name="Picture 1"/>
+          <p:cNvPicPr>
+            <a:picLocks noGrp="1" noChangeAspect="1"/>
+          </p:cNvPicPr>
+          <p:nvPr/>
+        </p:nvPicPr>
+        <p:blipFill>
+          <a:blip r:embed="rId2"/>
+          <a:stretch>
+            <a:fillRect/>
+          </a:stretch>
+        </p:blipFill>
+        <p:spPr bwMode="auto">
+          <a:xfrm>
+            <a:off x="3581400" y="203200"/>
+            <a:ext cx="5080000" cy="3873500"/>
+          </a:xfrm>
+          <a:prstGeom prst="rect">
+            <a:avLst/>
+          </a:prstGeom>
+          <a:noFill/>
+          <a:ln w="9525">
+            <a:noFill/>
+            <a:headEnd/>
+            <a:tailEnd/>
+          </a:ln>
+        </p:spPr>
+      </p:pic>
+      <p:sp>
+        <p:nvSpPr>
+          <p:cNvPr id="1" name="TextBox 3"/>
+          <p:cNvSpPr txBox="1"/>
+          <p:nvPr/>
+        </p:nvSpPr>
+        <p:spPr>
+          <a:xfrm>
+            <a:off x="3568700" y="4076700"/>
+            <a:ext cx="5105400" cy="508000"/>
+          </a:xfrm>
+          <a:prstGeom prst="rect">
+            <a:avLst/>
+          </a:prstGeom>
+          <a:noFill/>
+        </p:spPr>
+        <p:txBody>
+          <a:bodyPr/>
+          <a:lstStyle/>
+          <a:p>
+            <a:pPr lvl="0" indent="0" marL="0" algn="ctr">
               <a:buNone/>
             </a:pPr>
             <a:r>
               <a:rPr/>
-              <a:t>Avantages : rapide, léger, interprétable. Utilisé en production sur Azure F1.</a:t>
+              <a:t>Équilibre des classes</a:t>
             </a:r>
           </a:p>
         </p:txBody>
@@ -4181,12 +4534,12 @@
       </p:grpSpPr>
       <p:sp>
         <p:nvSpPr>
-          <p:cNvPr id="3" name="Content Placeholder 2"/>
-          <p:cNvSpPr>
-            <a:spLocks noGrp="1"/>
-          </p:cNvSpPr>
-          <p:nvPr>
-            <p:ph idx="1"/>
+          <p:cNvPr id="4" name="Text Placeholder 3"/>
+          <p:cNvSpPr>
+            <a:spLocks noGrp="1"/>
+          </p:cNvSpPr>
+          <p:nvPr>
+            <p:ph idx="2" sz="half" type="body"/>
           </p:nvPr>
         </p:nvSpPr>
         <p:spPr/>
@@ -4202,28 +4555,7 @@
             </a:pPr>
             <a:r>
               <a:rPr b="1"/>
-              <a:t>Slide 4 — Approche 2 : Deep Learning</a:t>
-            </a:r>
-          </a:p>
-          <a:p>
-            <a:pPr lvl="0"/>
-            <a:r>
-              <a:rPr/>
-              <a:t>CNN-LSTM hybride</a:t>
-            </a:r>
-          </a:p>
-          <a:p>
-            <a:pPr lvl="0"/>
-            <a:r>
-              <a:rPr/>
-              <a:t>Embeddings : Word2Vec vs GloVe</a:t>
-            </a:r>
-          </a:p>
-          <a:p>
-            <a:pPr lvl="0"/>
-            <a:r>
-              <a:rPr/>
-              <a:t>Early stopping sur validation</a:t>
+              <a:t>Slide 2c — Vocabulaire par sentiment</a:t>
             </a:r>
           </a:p>
           <a:p>
@@ -4232,7 +4564,67 @@
             </a:pPr>
             <a:r>
               <a:rPr/>
-              <a:t>Word2Vec ~65,7 % F1, GloVe ~69,4 % F1 sur 50k tweets.</a:t>
+              <a:t>Wordcloud des tweets positifs — le nettoyage (URLs, mentions, stopwords) fait ressortir le vocabulaire porteur de sentiment.</a:t>
+            </a:r>
+          </a:p>
+        </p:txBody>
+      </p:sp>
+      <p:pic>
+        <p:nvPicPr>
+          <p:cNvPr descr="screenshots/eda_wordclouds.png" id="0" name="Picture 1"/>
+          <p:cNvPicPr>
+            <a:picLocks noGrp="1" noChangeAspect="1"/>
+          </p:cNvPicPr>
+          <p:nvPr/>
+        </p:nvPicPr>
+        <p:blipFill>
+          <a:blip r:embed="rId2"/>
+          <a:stretch>
+            <a:fillRect/>
+          </a:stretch>
+        </p:blipFill>
+        <p:spPr bwMode="auto">
+          <a:xfrm>
+            <a:off x="4406900" y="203200"/>
+            <a:ext cx="3429000" cy="3873500"/>
+          </a:xfrm>
+          <a:prstGeom prst="rect">
+            <a:avLst/>
+          </a:prstGeom>
+          <a:noFill/>
+          <a:ln w="9525">
+            <a:noFill/>
+            <a:headEnd/>
+            <a:tailEnd/>
+          </a:ln>
+        </p:spPr>
+      </p:pic>
+      <p:sp>
+        <p:nvSpPr>
+          <p:cNvPr id="1" name="TextBox 3"/>
+          <p:cNvSpPr txBox="1"/>
+          <p:nvPr/>
+        </p:nvSpPr>
+        <p:spPr>
+          <a:xfrm>
+            <a:off x="3568700" y="4076700"/>
+            <a:ext cx="5105400" cy="508000"/>
+          </a:xfrm>
+          <a:prstGeom prst="rect">
+            <a:avLst/>
+          </a:prstGeom>
+          <a:noFill/>
+        </p:spPr>
+        <p:txBody>
+          <a:bodyPr/>
+          <a:lstStyle/>
+          <a:p>
+            <a:pPr lvl="0" indent="0" marL="0" algn="ctr">
+              <a:buNone/>
+            </a:pPr>
+            <a:r>
+              <a:rPr/>
+              <a:t>Wordcloud sentiments</a:t>
             </a:r>
           </a:p>
         </p:txBody>
@@ -4282,28 +4674,28 @@
             </a:pPr>
             <a:r>
               <a:rPr b="1"/>
-              <a:t>Slide 5 — Approche 3 : BERT</a:t>
+              <a:t>Slide 3 — Approche 1 : Modèles simples</a:t>
             </a:r>
           </a:p>
           <a:p>
             <a:pPr lvl="0"/>
             <a:r>
               <a:rPr/>
-              <a:t>DistilBERT fine-tuned</a:t>
+              <a:t>TF-IDF (5000 features)</a:t>
             </a:r>
           </a:p>
           <a:p>
             <a:pPr lvl="0"/>
             <a:r>
               <a:rPr/>
-              <a:t>2 epochs, échantillon stratifié 50k</a:t>
+              <a:t>Régression logistique : F1 test ~76,4 % (50k)</a:t>
             </a:r>
           </a:p>
           <a:p>
             <a:pPr lvl="0"/>
             <a:r>
-              <a:rPr b="1"/>
-              <a:t>Meilleur modèle entraîné : 81,5 % test accuracy, 81,5 % F1</a:t>
+              <a:rPr/>
+              <a:t>Random Forest : F1 test ~72,5 %</a:t>
             </a:r>
           </a:p>
           <a:p>
@@ -4312,7 +4704,7 @@
             </a:pPr>
             <a:r>
               <a:rPr/>
-              <a:t>Sélectionné comme modèle de référence ; fallback logistic sur Azure F1 (mémoire).</a:t>
+              <a:t>Avantages : rapide, léger, interprétable. Utilisé en production sur Azure F1.</a:t>
             </a:r>
           </a:p>
         </p:txBody>
@@ -4323,6 +4715,166 @@
 </file>
 
 <file path=ppt/slides/slide7.xml><?xml version="1.0" encoding="utf-8"?>
+<p:sld xmlns:a="http://schemas.openxmlformats.org/drawingml/2006/main" xmlns:r="http://schemas.openxmlformats.org/officeDocument/2006/relationships" xmlns:p="http://schemas.openxmlformats.org/presentationml/2006/main">
+  <p:cSld>
+    <p:spTree>
+      <p:nvGrpSpPr>
+        <p:cNvPr id="1" name=""/>
+        <p:cNvGrpSpPr/>
+        <p:nvPr/>
+      </p:nvGrpSpPr>
+      <p:grpSpPr>
+        <a:xfrm>
+          <a:off x="0" y="0"/>
+          <a:ext cx="0" cy="0"/>
+          <a:chOff x="0" y="0"/>
+          <a:chExt cx="0" cy="0"/>
+        </a:xfrm>
+      </p:grpSpPr>
+      <p:sp>
+        <p:nvSpPr>
+          <p:cNvPr id="3" name="Content Placeholder 2"/>
+          <p:cNvSpPr>
+            <a:spLocks noGrp="1"/>
+          </p:cNvSpPr>
+          <p:nvPr>
+            <p:ph idx="1"/>
+          </p:nvPr>
+        </p:nvSpPr>
+        <p:spPr/>
+        <p:txBody>
+          <a:bodyPr/>
+          <a:lstStyle/>
+          <a:p>
+            <a:pPr lvl="0" indent="0" marL="0">
+              <a:spcBef>
+                <a:spcPts val="3000"/>
+              </a:spcBef>
+              <a:buNone/>
+            </a:pPr>
+            <a:r>
+              <a:rPr b="1"/>
+              <a:t>Slide 4 — Approche 2 : Deep Learning</a:t>
+            </a:r>
+          </a:p>
+          <a:p>
+            <a:pPr lvl="0"/>
+            <a:r>
+              <a:rPr/>
+              <a:t>CNN-LSTM hybride</a:t>
+            </a:r>
+          </a:p>
+          <a:p>
+            <a:pPr lvl="0"/>
+            <a:r>
+              <a:rPr/>
+              <a:t>Embeddings : Word2Vec vs GloVe</a:t>
+            </a:r>
+          </a:p>
+          <a:p>
+            <a:pPr lvl="0"/>
+            <a:r>
+              <a:rPr/>
+              <a:t>Early stopping sur validation</a:t>
+            </a:r>
+          </a:p>
+          <a:p>
+            <a:pPr lvl="0" indent="0" marL="0">
+              <a:buNone/>
+            </a:pPr>
+            <a:r>
+              <a:rPr/>
+              <a:t>Word2Vec ~65,7 % F1, GloVe ~69,4 % F1 sur 50k tweets.</a:t>
+            </a:r>
+          </a:p>
+        </p:txBody>
+      </p:sp>
+    </p:spTree>
+  </p:cSld>
+</p:sld>
+</file>
+
+<file path=ppt/slides/slide8.xml><?xml version="1.0" encoding="utf-8"?>
+<p:sld xmlns:a="http://schemas.openxmlformats.org/drawingml/2006/main" xmlns:r="http://schemas.openxmlformats.org/officeDocument/2006/relationships" xmlns:p="http://schemas.openxmlformats.org/presentationml/2006/main">
+  <p:cSld>
+    <p:spTree>
+      <p:nvGrpSpPr>
+        <p:cNvPr id="1" name=""/>
+        <p:cNvGrpSpPr/>
+        <p:nvPr/>
+      </p:nvGrpSpPr>
+      <p:grpSpPr>
+        <a:xfrm>
+          <a:off x="0" y="0"/>
+          <a:ext cx="0" cy="0"/>
+          <a:chOff x="0" y="0"/>
+          <a:chExt cx="0" cy="0"/>
+        </a:xfrm>
+      </p:grpSpPr>
+      <p:sp>
+        <p:nvSpPr>
+          <p:cNvPr id="3" name="Content Placeholder 2"/>
+          <p:cNvSpPr>
+            <a:spLocks noGrp="1"/>
+          </p:cNvSpPr>
+          <p:nvPr>
+            <p:ph idx="1"/>
+          </p:nvPr>
+        </p:nvSpPr>
+        <p:spPr/>
+        <p:txBody>
+          <a:bodyPr/>
+          <a:lstStyle/>
+          <a:p>
+            <a:pPr lvl="0" indent="0" marL="0">
+              <a:spcBef>
+                <a:spcPts val="3000"/>
+              </a:spcBef>
+              <a:buNone/>
+            </a:pPr>
+            <a:r>
+              <a:rPr b="1"/>
+              <a:t>Slide 5 — Approche 3 : BERT</a:t>
+            </a:r>
+          </a:p>
+          <a:p>
+            <a:pPr lvl="0"/>
+            <a:r>
+              <a:rPr/>
+              <a:t>DistilBERT fine-tuned</a:t>
+            </a:r>
+          </a:p>
+          <a:p>
+            <a:pPr lvl="0"/>
+            <a:r>
+              <a:rPr/>
+              <a:t>2 epochs, échantillon stratifié 50k</a:t>
+            </a:r>
+          </a:p>
+          <a:p>
+            <a:pPr lvl="0"/>
+            <a:r>
+              <a:rPr b="1"/>
+              <a:t>Meilleur modèle entraîné : 81,5 % test accuracy, 81,5 % F1</a:t>
+            </a:r>
+          </a:p>
+          <a:p>
+            <a:pPr lvl="0" indent="0" marL="0">
+              <a:buNone/>
+            </a:pPr>
+            <a:r>
+              <a:rPr/>
+              <a:t>Sélectionné comme modèle de référence ; fallback logistic sur Azure F1 (mémoire).</a:t>
+            </a:r>
+          </a:p>
+        </p:txBody>
+      </p:sp>
+    </p:spTree>
+  </p:cSld>
+</p:sld>
+</file>
+
+<file path=ppt/slides/slide9.xml><?xml version="1.0" encoding="utf-8"?>
 <p:sld xmlns:a="http://schemas.openxmlformats.org/drawingml/2006/main" xmlns:r="http://schemas.openxmlformats.org/officeDocument/2006/relationships" xmlns:p="http://schemas.openxmlformats.org/presentationml/2006/main">
   <p:cSld>
     <p:spTree>
@@ -4589,313 +5141,6 @@
           </a:graphicData>
         </a:graphic>
       </p:graphicFrame>
-    </p:spTree>
-  </p:cSld>
-</p:sld>
-</file>
-
-<file path=ppt/slides/slide8.xml><?xml version="1.0" encoding="utf-8"?>
-<p:sld xmlns:a="http://schemas.openxmlformats.org/drawingml/2006/main" xmlns:r="http://schemas.openxmlformats.org/officeDocument/2006/relationships" xmlns:p="http://schemas.openxmlformats.org/presentationml/2006/main">
-  <p:cSld>
-    <p:spTree>
-      <p:nvGrpSpPr>
-        <p:cNvPr id="1" name=""/>
-        <p:cNvGrpSpPr/>
-        <p:nvPr/>
-      </p:nvGrpSpPr>
-      <p:grpSpPr>
-        <a:xfrm>
-          <a:off x="0" y="0"/>
-          <a:ext cx="0" cy="0"/>
-          <a:chOff x="0" y="0"/>
-          <a:chExt cx="0" cy="0"/>
-        </a:xfrm>
-      </p:grpSpPr>
-      <p:pic>
-        <p:nvPicPr>
-          <p:cNvPr descr="screenshots/mlflow_model_comparison.png" id="0" name="Picture 1"/>
-          <p:cNvPicPr>
-            <a:picLocks noGrp="1" noChangeAspect="1"/>
-          </p:cNvPicPr>
-          <p:nvPr/>
-        </p:nvPicPr>
-        <p:blipFill>
-          <a:blip r:embed="rId2"/>
-          <a:stretch>
-            <a:fillRect/>
-          </a:stretch>
-        </p:blipFill>
-        <p:spPr bwMode="auto">
-          <a:xfrm>
-            <a:off x="1689100" y="1193800"/>
-            <a:ext cx="5765800" cy="2882900"/>
-          </a:xfrm>
-          <a:prstGeom prst="rect">
-            <a:avLst/>
-          </a:prstGeom>
-          <a:noFill/>
-          <a:ln w="9525">
-            <a:noFill/>
-            <a:headEnd/>
-            <a:tailEnd/>
-          </a:ln>
-        </p:spPr>
-      </p:pic>
-      <p:sp>
-        <p:nvSpPr>
-          <p:cNvPr id="1" name="TextBox 3"/>
-          <p:cNvSpPr txBox="1"/>
-          <p:nvPr/>
-        </p:nvSpPr>
-        <p:spPr>
-          <a:xfrm>
-            <a:off x="457200" y="4076700"/>
-            <a:ext cx="8229600" cy="508000"/>
-          </a:xfrm>
-          <a:prstGeom prst="rect">
-            <a:avLst/>
-          </a:prstGeom>
-          <a:noFill/>
-        </p:spPr>
-        <p:txBody>
-          <a:bodyPr/>
-          <a:lstStyle/>
-          <a:p>
-            <a:pPr lvl="0" indent="0" marL="0" algn="ctr">
-              <a:buNone/>
-            </a:pPr>
-            <a:r>
-              <a:rPr/>
-              <a:t>Comparaison MLflow</a:t>
-            </a:r>
-          </a:p>
-        </p:txBody>
-      </p:sp>
-      <p:pic>
-        <p:nvPicPr>
-          <p:cNvPr descr="screenshots/mlflow_ui_runs.png" id="0" name="Picture 1"/>
-          <p:cNvPicPr>
-            <a:picLocks noGrp="1" noChangeAspect="1"/>
-          </p:cNvPicPr>
-          <p:nvPr/>
-        </p:nvPicPr>
-        <p:blipFill>
-          <a:blip r:embed="rId3"/>
-          <a:stretch>
-            <a:fillRect/>
-          </a:stretch>
-        </p:blipFill>
-        <p:spPr bwMode="auto">
-          <a:xfrm>
-            <a:off x="457200" y="1358900"/>
-            <a:ext cx="8229600" cy="2565400"/>
-          </a:xfrm>
-          <a:prstGeom prst="rect">
-            <a:avLst/>
-          </a:prstGeom>
-          <a:noFill/>
-          <a:ln w="9525">
-            <a:noFill/>
-            <a:headEnd/>
-            <a:tailEnd/>
-          </a:ln>
-        </p:spPr>
-      </p:pic>
-      <p:sp>
-        <p:nvSpPr>
-          <p:cNvPr id="1" name="TextBox 3"/>
-          <p:cNvSpPr txBox="1"/>
-          <p:nvPr/>
-        </p:nvSpPr>
-        <p:spPr>
-          <a:xfrm>
-            <a:off x="457200" y="4076700"/>
-            <a:ext cx="8229600" cy="508000"/>
-          </a:xfrm>
-          <a:prstGeom prst="rect">
-            <a:avLst/>
-          </a:prstGeom>
-          <a:noFill/>
-        </p:spPr>
-        <p:txBody>
-          <a:bodyPr/>
-          <a:lstStyle/>
-          <a:p>
-            <a:pPr lvl="0" indent="0" marL="0" algn="ctr">
-              <a:buNone/>
-            </a:pPr>
-            <a:r>
-              <a:rPr/>
-              <a:t>MLflow UI — runs</a:t>
-            </a:r>
-          </a:p>
-        </p:txBody>
-      </p:sp>
-    </p:spTree>
-  </p:cSld>
-</p:sld>
-</file>
-
-<file path=ppt/slides/slide9.xml><?xml version="1.0" encoding="utf-8"?>
-<p:sld xmlns:a="http://schemas.openxmlformats.org/drawingml/2006/main" xmlns:r="http://schemas.openxmlformats.org/officeDocument/2006/relationships" xmlns:p="http://schemas.openxmlformats.org/presentationml/2006/main">
-  <p:cSld>
-    <p:spTree>
-      <p:nvGrpSpPr>
-        <p:cNvPr id="1" name=""/>
-        <p:cNvGrpSpPr/>
-        <p:nvPr/>
-      </p:nvGrpSpPr>
-      <p:grpSpPr>
-        <a:xfrm>
-          <a:off x="0" y="0"/>
-          <a:ext cx="0" cy="0"/>
-          <a:chOff x="0" y="0"/>
-          <a:chExt cx="0" cy="0"/>
-        </a:xfrm>
-      </p:grpSpPr>
-      <p:sp>
-        <p:nvSpPr>
-          <p:cNvPr id="4" name="Text Placeholder 3"/>
-          <p:cNvSpPr>
-            <a:spLocks noGrp="1"/>
-          </p:cNvSpPr>
-          <p:nvPr>
-            <p:ph idx="2" sz="half" type="body"/>
-          </p:nvPr>
-        </p:nvSpPr>
-        <p:spPr/>
-        <p:txBody>
-          <a:bodyPr/>
-          <a:lstStyle/>
-          <a:p>
-            <a:pPr lvl="0" indent="0" marL="0">
-              <a:spcBef>
-                <a:spcPts val="3000"/>
-              </a:spcBef>
-              <a:buNone/>
-            </a:pPr>
-            <a:r>
-              <a:rPr b="1"/>
-              <a:t>Slide 7 — MLOps : principes</a:t>
-            </a:r>
-          </a:p>
-          <a:p>
-            <a:pPr lvl="0"/>
-            <a:r>
-              <a:rPr b="1"/>
-              <a:t>Tracking</a:t>
-            </a:r>
-            <a:r>
-              <a:rPr/>
-              <a:t> : MLflow (params, metrics, artifacts)</a:t>
-            </a:r>
-          </a:p>
-          <a:p>
-            <a:pPr lvl="0"/>
-            <a:r>
-              <a:rPr b="1"/>
-              <a:t>Versioning</a:t>
-            </a:r>
-            <a:r>
-              <a:rPr/>
-              <a:t> : Git + GitHub</a:t>
-            </a:r>
-          </a:p>
-          <a:p>
-            <a:pPr lvl="0"/>
-            <a:r>
-              <a:rPr b="1"/>
-              <a:t>Tests</a:t>
-            </a:r>
-            <a:r>
-              <a:rPr/>
-              <a:t> : pytest (11 tests)</a:t>
-            </a:r>
-          </a:p>
-          <a:p>
-            <a:pPr lvl="0"/>
-            <a:r>
-              <a:rPr b="1"/>
-              <a:t>CI/CD</a:t>
-            </a:r>
-            <a:r>
-              <a:rPr/>
-              <a:t> : GitHub Actions</a:t>
-            </a:r>
-          </a:p>
-          <a:p>
-            <a:pPr lvl="0"/>
-            <a:r>
-              <a:rPr b="1"/>
-              <a:t>Monitoring</a:t>
-            </a:r>
-            <a:r>
-              <a:rPr/>
-              <a:t> : Azure Application Insights</a:t>
-            </a:r>
-          </a:p>
-        </p:txBody>
-      </p:sp>
-      <p:pic>
-        <p:nvPicPr>
-          <p:cNvPr descr="screenshots/github_actions_ci.png" id="0" name="Picture 1"/>
-          <p:cNvPicPr>
-            <a:picLocks noGrp="1" noChangeAspect="1"/>
-          </p:cNvPicPr>
-          <p:nvPr/>
-        </p:nvPicPr>
-        <p:blipFill>
-          <a:blip r:embed="rId2"/>
-          <a:stretch>
-            <a:fillRect/>
-          </a:stretch>
-        </p:blipFill>
-        <p:spPr bwMode="auto">
-          <a:xfrm>
-            <a:off x="3568700" y="711200"/>
-            <a:ext cx="5105400" cy="2870200"/>
-          </a:xfrm>
-          <a:prstGeom prst="rect">
-            <a:avLst/>
-          </a:prstGeom>
-          <a:noFill/>
-          <a:ln w="9525">
-            <a:noFill/>
-            <a:headEnd/>
-            <a:tailEnd/>
-          </a:ln>
-        </p:spPr>
-      </p:pic>
-      <p:sp>
-        <p:nvSpPr>
-          <p:cNvPr id="1" name="TextBox 3"/>
-          <p:cNvSpPr txBox="1"/>
-          <p:nvPr/>
-        </p:nvSpPr>
-        <p:spPr>
-          <a:xfrm>
-            <a:off x="3568700" y="4076700"/>
-            <a:ext cx="5105400" cy="508000"/>
-          </a:xfrm>
-          <a:prstGeom prst="rect">
-            <a:avLst/>
-          </a:prstGeom>
-          <a:noFill/>
-        </p:spPr>
-        <p:txBody>
-          <a:bodyPr/>
-          <a:lstStyle/>
-          <a:p>
-            <a:pPr lvl="0" indent="0" marL="0" algn="ctr">
-              <a:buNone/>
-            </a:pPr>
-            <a:r>
-              <a:rPr/>
-              <a:t>GitHub Actions CI</a:t>
-            </a:r>
-          </a:p>
-        </p:txBody>
-      </p:sp>
     </p:spTree>
   </p:cSld>
 </p:sld>

</xml_diff>